<commit_message>
L03: publish The Big Three
Adds the bullseye diagram the lecture kept naming but never drew, and the
prompt spectrum, which replaces a definition slide with the judgement
students actually have to make: outcome on the left, implementation on the
right, aim for the interface in between.

The demo flow slide now matches the rehearsed runbook step for step. It
previously named a path that does not exist here and gave commands that
fail if you type them, which mattered because the caption invites students
to run the demo again at home.

Speaker notes on every slide but the end card. They are the only prose that
ships with a deck, so slides that carried a heading and a bullet list now
carry the reasoning behind them too.
</commit_message>
<xml_diff>
--- a/lectures/L03/slides.pptx
+++ b/lectures/L03/slides.pptx
@@ -51,9 +51,10 @@
     <p:sldId id="299" r:id="rId45"/>
     <p:sldId id="300" r:id="rId46"/>
     <p:sldId id="301" r:id="rId47"/>
+    <p:sldId id="302" r:id="rId48"/>
   </p:sldIdLst>
   <p:notesMasterIdLst>
-    <p:notesMasterId r:id="rId48"/>
+    <p:notesMasterId r:id="rId49"/>
   </p:notesMasterIdLst>
   <p:sldSz cx="9334500" cy="5248275"/>
   <p:notesSz cx="5248275" cy="9334500"/>
@@ -636,7 +637,12 @@
           <a:p>
             <a:r>
               <a:rPr lang="en-US" dirty="0"/>
-              <a:t/>
+              <a:t>Added files are the only files the model can edit. Say that twice.
+The repo map is an auto-generated summary, not a substitute for adding the
+file.
+Chat history accumulates until /clear. That is the second pitfall, two
+slides from now.
+The system prompt is Aider's own, and the default is fine for now.</a:t>
             </a:r>
             <a:endParaRPr lang="en-US" dirty="0"/>
           </a:p>
@@ -724,7 +730,12 @@
           <a:p>
             <a:r>
               <a:rPr lang="en-US" dirty="0"/>
-              <a:t/>
+              <a:t>Added files are the only files the model can edit. Say that twice.
+The repo map is an auto-generated summary, not a substitute for adding the
+file.
+Chat history accumulates until /clear. That is the second pitfall, two
+slides from now.
+The system prompt is Aider's own, and the default is fine for now.</a:t>
             </a:r>
             <a:endParaRPr lang="en-US" dirty="0"/>
           </a:p>
@@ -812,7 +823,12 @@
           <a:p>
             <a:r>
               <a:rPr lang="en-US" dirty="0"/>
-              <a:t/>
+              <a:t>Added files are the only files the model can edit. Say that twice.
+The repo map is an auto-generated summary, not a substitute for adding the
+file.
+Chat history accumulates until /clear. That is the second pitfall, two
+slides from now.
+The system prompt is Aider's own, and the default is fine for now.</a:t>
             </a:r>
             <a:endParaRPr lang="en-US" dirty="0"/>
           </a:p>
@@ -900,7 +916,12 @@
           <a:p>
             <a:r>
               <a:rPr lang="en-US" dirty="0"/>
-              <a:t/>
+              <a:t>Added files are the only files the model can edit. Say that twice.
+The repo map is an auto-generated summary, not a substitute for adding the
+file.
+Chat history accumulates until /clear. That is the second pitfall, two
+slides from now.
+The system prompt is Aider's own, and the default is fine for now.</a:t>
             </a:r>
             <a:endParaRPr lang="en-US" dirty="0"/>
           </a:p>
@@ -1076,7 +1097,11 @@
           <a:p>
             <a:r>
               <a:rPr lang="en-US" dirty="0"/>
-              <a:t/>
+              <a:t>Three questions, asked before every task, not once at the start of a
+session.
+Only the first card can be edited at all. The second is what the model has
+to read to get the first right.
+Reference is usually where the repo map is already enough.</a:t>
             </a:r>
             <a:endParaRPr lang="en-US" dirty="0"/>
           </a:p>
@@ -1254,7 +1279,15 @@
           <a:p>
             <a:r>
               <a:rPr lang="en-US" dirty="0"/>
-              <a:t/>
+              <a:t>Missing context is the most common failure in this course. The model edits
+what is in context, so a file that was never added cannot be fixed. Aider
+offers to add it and taking the offer saves you. Decline it, or use a tool
+that does not ask, and one file gets updated alone: a partial change that
+looks finished.
+History bleed is subtler. Ten minutes on task A, start task B, and those
+messages are still sitting there carrying assumptions. /clear resets the
+conversation and keeps the files.
+This sets up the break. Do not answer it here.</a:t>
             </a:r>
             <a:endParaRPr lang="en-US" dirty="0"/>
           </a:p>
@@ -1433,7 +1466,9 @@
           <a:p>
             <a:r>
               <a:rPr lang="en-US" dirty="0"/>
-              <a:t/>
+              <a:t>Context is what you feed the model. This is the other half of the same
+decision.
+Ten minutes here, then prompt.</a:t>
             </a:r>
             <a:endParaRPr lang="en-US" dirty="0"/>
           </a:p>
@@ -1611,7 +1646,11 @@
           <a:p>
             <a:r>
               <a:rPr lang="en-US" dirty="0"/>
-              <a:t/>
+              <a:t>Speed and size track reasoning ability. Smarter tends to be bigger, which
+on their own hardware means slower and hungrier for RAM rather than more
+expensive in dollars. The tradeoff does not disappear when the bill does.
+Some models do 128K, some do 1M, and L02 already told them bigger is not
+automatically better. Needle in a haystack is real.</a:t>
             </a:r>
             <a:endParaRPr lang="en-US" dirty="0"/>
           </a:p>
@@ -1699,7 +1738,11 @@
           <a:p>
             <a:r>
               <a:rPr lang="en-US" dirty="0"/>
-              <a:t/>
+              <a:t>Speed and size track reasoning ability. Smarter tends to be bigger, which
+on their own hardware means slower and hungrier for RAM rather than more
+expensive in dollars. The tradeoff does not disappear when the bill does.
+Some models do 128K, some do 1M, and L02 already told them bigger is not
+automatically better. Needle in a haystack is real.</a:t>
             </a:r>
             <a:endParaRPr lang="en-US" dirty="0"/>
           </a:p>
@@ -1787,7 +1830,11 @@
           <a:p>
             <a:r>
               <a:rPr lang="en-US" dirty="0"/>
-              <a:t/>
+              <a:t>Speed and size track reasoning ability. Smarter tends to be bigger, which
+on their own hardware means slower and hungrier for RAM rather than more
+expensive in dollars. The tradeoff does not disappear when the bill does.
+Some models do 128K, some do 1M, and L02 already told them bigger is not
+automatically better. Needle in a haystack is real.</a:t>
             </a:r>
             <a:endParaRPr lang="en-US" dirty="0"/>
           </a:p>
@@ -1875,7 +1922,11 @@
           <a:p>
             <a:r>
               <a:rPr lang="en-US" dirty="0"/>
-              <a:t/>
+              <a:t>Speed and size track reasoning ability. Smarter tends to be bigger, which
+on their own hardware means slower and hungrier for RAM rather than more
+expensive in dollars. The tradeoff does not disappear when the bill does.
+Some models do 128K, some do 1M, and L02 already told them bigger is not
+automatically better. Needle in a haystack is real.</a:t>
             </a:r>
             <a:endParaRPr lang="en-US" dirty="0"/>
           </a:p>
@@ -1963,7 +2014,11 @@
           <a:p>
             <a:r>
               <a:rPr lang="en-US" dirty="0"/>
-              <a:t/>
+              <a:t>Speed and size track reasoning ability. Smarter tends to be bigger, which
+on their own hardware means slower and hungrier for RAM rather than more
+expensive in dollars. The tradeoff does not disappear when the bill does.
+Some models do 128K, some do 1M, and L02 already told them bigger is not
+automatically better. Needle in a haystack is real.</a:t>
             </a:r>
             <a:endParaRPr lang="en-US" dirty="0"/>
           </a:p>
@@ -2051,7 +2106,9 @@
           <a:p>
             <a:r>
               <a:rPr lang="en-US" dirty="0"/>
-              <a:t/>
+              <a:t>Per task, not per term. That is the whole slide.
+The leaderboard is worth knowing, and it is a proxy for their task rather
+than a substitute for running their task.</a:t>
             </a:r>
             <a:endParaRPr lang="en-US" dirty="0"/>
           </a:p>
@@ -2228,7 +2285,8 @@
           <a:p>
             <a:r>
               <a:rPr lang="en-US" dirty="0"/>
-              <a:t/>
+              <a:t>The last lever, and the shortest section, because L04 is the whole lecture
+on it.</a:t>
             </a:r>
             <a:endParaRPr lang="en-US" dirty="0"/>
           </a:p>
@@ -2316,7 +2374,22 @@
           <a:p>
             <a:r>
               <a:rPr lang="en-US" dirty="0"/>
-              <a:t/>
+              <a:t>Prompts have two parts. The instruction is what you want done. The intent
+is the reason you want it done that way. Leave the intent out and the model
+fills it from training-data priors, a guess you never got to see.
+The line this slide rests on: specification closes decisions, intent steers
+the ones you left open. That is why one is a band and the other is an
+arrow. Say it before you explain the arrow.
+Then pre-empt the misread: the arrow is not telling them to be vaguer, it
+is telling them the target gets wider on that end when you say why. Intent
+extends the left edge and does nothing to the right edge, because it cannot
+rescue you from having already written the code yourself.
+Aim for the interface: name the file, the function, the signature, the call
+site, and stop. You own the seam, the model writes the body.
+Required, not optional: the arrow has a length and its length is model
+capability. On the 4B it is short. A paragraph of why can bury the one
+sentence of what, which is L02's needle in a haystack aimed at their own
+prompt. Keep intent to a clause this term.</a:t>
             </a:r>
             <a:endParaRPr lang="en-US" dirty="0"/>
           </a:p>
@@ -2404,7 +2477,12 @@
           <a:p>
             <a:r>
               <a:rPr lang="en-US" dirty="0"/>
-              <a:t/>
+              <a:t>The vague one sets a direction and leaves every specific decision to the
+model. It is not wrong, it is unpredictable, and unpredictable is the
+problem.
+The specific one is longer to write and faster to use. Predictability is
+the goal, not brevity.
+L04 formalizes this as an IDK prompt.</a:t>
             </a:r>
             <a:endParaRPr lang="en-US" dirty="0"/>
           </a:p>
@@ -2492,7 +2570,10 @@
           <a:p>
             <a:r>
               <a:rPr lang="en-US" dirty="0"/>
-              <a:t/>
+              <a:t>L02 gave them tokenization, the context window, hallucination, capability
+against knowledge. That was the mechanics. This is the framework on top.
+Three choices in every session. Get one wrong and no amount of effort in
+the other two saves you.</a:t>
             </a:r>
             <a:endParaRPr lang="en-US" dirty="0"/>
           </a:p>
@@ -2580,8 +2661,10 @@
           <a:p>
             <a:r>
               <a:rPr lang="en-US" dirty="0"/>
-              <a:t>Specify outcome, not implementation. But "what" must be specific.
-"What &gt; How" ≠ "be vague and AI will figure it out."</a:t>
+              <a:t>Specify outcome, not implementation. But "what" has to be specific enough
+to succeed.
+Sharper now that they have the spectrum: specify down to the interface and
+stop there. "What &gt; How" is not "be vague and the AI will figure it out."</a:t>
             </a:r>
             <a:endParaRPr lang="en-US" dirty="0"/>
           </a:p>
@@ -2624,6 +2707,98 @@
 </file>
 
 <file path=ppt/notesSlides/notesSlide31.xml><?xml version="1.0" encoding="utf-8"?>
+<p:notes xmlns:a="http://schemas.openxmlformats.org/drawingml/2006/main" xmlns:r="http://schemas.openxmlformats.org/officeDocument/2006/relationships" xmlns:p="http://schemas.openxmlformats.org/presentationml/2006/main">
+  <p:cSld>
+    <p:spTree>
+      <p:nvGrpSpPr>
+        <p:cNvPr id="1" name=""/>
+        <p:cNvGrpSpPr/>
+        <p:nvPr/>
+      </p:nvGrpSpPr>
+      <p:grpSpPr>
+        <a:xfrm>
+          <a:off x="0" y="0"/>
+          <a:ext cx="0" cy="0"/>
+          <a:chOff x="0" y="0"/>
+          <a:chExt cx="0" cy="0"/>
+        </a:xfrm>
+      </p:grpSpPr>
+      <p:sp>
+        <p:nvSpPr>
+          <p:cNvPr id="2" name="Slide Image Placeholder 1"/>
+          <p:cNvSpPr>
+            <a:spLocks noGrp="1" noRot="1" noChangeAspect="1"/>
+          </p:cNvSpPr>
+          <p:nvPr>
+            <p:ph type="sldImg"/>
+          </p:nvPr>
+        </p:nvSpPr>
+        <p:spPr/>
+      </p:sp>
+      <p:sp>
+        <p:nvSpPr>
+          <p:cNvPr id="3" name="Notes Placeholder 2"/>
+          <p:cNvSpPr>
+            <a:spLocks noGrp="1"/>
+          </p:cNvSpPr>
+          <p:nvPr>
+            <p:ph type="body" idx="1"/>
+          </p:nvPr>
+        </p:nvSpPr>
+        <p:spPr/>
+        <p:txBody>
+          <a:bodyPr/>
+          <a:lstStyle/>
+          <a:p>
+            <a:r>
+              <a:rPr lang="en-US" dirty="0"/>
+              <a:t>The recap before the demo. Each lever is one of last lecture's mechanics
+with a handle on it.
+Land this: every piece of prompting advice they will ever read reduces to
+one of these three. "Add the file" exploits the window. "Be specific"
+exploits the priors.</a:t>
+            </a:r>
+            <a:endParaRPr lang="en-US" dirty="0"/>
+          </a:p>
+        </p:txBody>
+      </p:sp>
+      <p:sp>
+        <p:nvSpPr>
+          <p:cNvPr id="4" name="Slide Number Placeholder 3"/>
+          <p:cNvSpPr>
+            <a:spLocks noGrp="1"/>
+          </p:cNvSpPr>
+          <p:nvPr>
+            <p:ph type="sldNum" sz="quarter" idx="10"/>
+          </p:nvPr>
+        </p:nvSpPr>
+        <p:spPr/>
+        <p:txBody>
+          <a:bodyPr/>
+          <a:lstStyle/>
+          <a:p>
+            <a:fld id="{F7021451-1387-4CA6-816F-3879F97B5CBC}" type="slidenum">
+              <a:rPr lang="en-US"/>
+              <a:t>31</a:t>
+            </a:fld>
+            <a:endParaRPr lang="en-US"/>
+          </a:p>
+        </p:txBody>
+      </p:sp>
+    </p:spTree>
+    <p:extLst>
+      <p:ext uri="{BB962C8B-B14F-4D97-AF65-F5344CB8AC3E}">
+        <p14:creationId xmlns:p14="http://schemas.microsoft.com/office/powerpoint/2010/main" val="1024086991"/>
+      </p:ext>
+    </p:extLst>
+  </p:cSld>
+  <p:clrMapOvr>
+    <a:masterClrMapping/>
+  </p:clrMapOvr>
+</p:notes>
+</file>
+
+<file path=ppt/notesSlides/notesSlide32.xml><?xml version="1.0" encoding="utf-8"?>
 <p:notes xmlns:a="http://schemas.openxmlformats.org/drawingml/2006/main" xmlns:r="http://schemas.openxmlformats.org/officeDocument/2006/relationships" xmlns:p="http://schemas.openxmlformats.org/presentationml/2006/main">
   <p:cSld>
     <p:spTree>
@@ -2693,7 +2868,7 @@
           <a:p>
             <a:fld id="{F7021451-1387-4CA6-816F-3879F97B5CBC}" type="slidenum">
               <a:rPr lang="en-US"/>
-              <a:t>31</a:t>
+              <a:t>32</a:t>
             </a:fld>
             <a:endParaRPr lang="en-US"/>
           </a:p>
@@ -2712,7 +2887,7 @@
 </p:notes>
 </file>
 
-<file path=ppt/notesSlides/notesSlide32.xml><?xml version="1.0" encoding="utf-8"?>
+<file path=ppt/notesSlides/notesSlide33.xml><?xml version="1.0" encoding="utf-8"?>
 <p:notes xmlns:a="http://schemas.openxmlformats.org/drawingml/2006/main" xmlns:r="http://schemas.openxmlformats.org/officeDocument/2006/relationships" xmlns:p="http://schemas.openxmlformats.org/presentationml/2006/main">
   <p:cSld>
     <p:spTree>
@@ -2758,7 +2933,22 @@
           <a:p>
             <a:r>
               <a:rPr lang="en-US" dirty="0"/>
-              <a:t/>
+              <a:t>Five files. arg_parse.py owns every command-line flag, main.py owns the
+counting and the printing. Say that out loud before you start, because the
+whole demo turns on it.
+Step 2 is the moment: it proposes a rewrite of a file it has never read,
+and what is on screen is a diff, so the minus lines are a line-by-line
+inventory of what it got wrong. Point at -default=DEFAULT_TOP_N against
++default=10.
+Two prompts to decline there, not one. The second one defaults to Yes, and
+taking the default writes the invented file to disk and loses the demo.
+Step 4 is the lecture in one sentence: same model, same prompt, one more
+file.
+Step 6 drops and re-adds on purpose. Without it all five files are still in
+context and the 4B cannot reproduce the failure. Same mistake, faster: the
+failure was never the model.
+If a step misbehaves, say the sentence and move on. The model can only
+change files that are in context.</a:t>
             </a:r>
             <a:endParaRPr lang="en-US" dirty="0"/>
           </a:p>
@@ -2781,7 +2971,7 @@
           <a:p>
             <a:fld id="{F7021451-1387-4CA6-816F-3879F97B5CBC}" type="slidenum">
               <a:rPr lang="en-US"/>
-              <a:t>32</a:t>
+              <a:t>33</a:t>
             </a:fld>
             <a:endParaRPr lang="en-US"/>
           </a:p>
@@ -2800,7 +2990,7 @@
 </p:notes>
 </file>
 
-<file path=ppt/notesSlides/notesSlide33.xml><?xml version="1.0" encoding="utf-8"?>
+<file path=ppt/notesSlides/notesSlide34.xml><?xml version="1.0" encoding="utf-8"?>
 <p:notes xmlns:a="http://schemas.openxmlformats.org/drawingml/2006/main" xmlns:r="http://schemas.openxmlformats.org/officeDocument/2006/relationships" xmlns:p="http://schemas.openxmlformats.org/presentationml/2006/main">
   <p:cSld>
     <p:spTree>
@@ -2846,7 +3036,22 @@
           <a:p>
             <a:r>
               <a:rPr lang="en-US" dirty="0"/>
-              <a:t/>
+              <a:t>Five files. arg_parse.py owns every command-line flag, main.py owns the
+counting and the printing. Say that out loud before you start, because the
+whole demo turns on it.
+Step 2 is the moment: it proposes a rewrite of a file it has never read,
+and what is on screen is a diff, so the minus lines are a line-by-line
+inventory of what it got wrong. Point at -default=DEFAULT_TOP_N against
++default=10.
+Two prompts to decline there, not one. The second one defaults to Yes, and
+taking the default writes the invented file to disk and loses the demo.
+Step 4 is the lecture in one sentence: same model, same prompt, one more
+file.
+Step 6 drops and re-adds on purpose. Without it all five files are still in
+context and the 4B cannot reproduce the failure. Same mistake, faster: the
+failure was never the model.
+If a step misbehaves, say the sentence and move on. The model can only
+change files that are in context.</a:t>
             </a:r>
             <a:endParaRPr lang="en-US" dirty="0"/>
           </a:p>
@@ -2869,7 +3074,7 @@
           <a:p>
             <a:fld id="{F7021451-1387-4CA6-816F-3879F97B5CBC}" type="slidenum">
               <a:rPr lang="en-US"/>
-              <a:t>33</a:t>
+              <a:t>34</a:t>
             </a:fld>
             <a:endParaRPr lang="en-US"/>
           </a:p>
@@ -2888,7 +3093,7 @@
 </p:notes>
 </file>
 
-<file path=ppt/notesSlides/notesSlide34.xml><?xml version="1.0" encoding="utf-8"?>
+<file path=ppt/notesSlides/notesSlide35.xml><?xml version="1.0" encoding="utf-8"?>
 <p:notes xmlns:a="http://schemas.openxmlformats.org/drawingml/2006/main" xmlns:r="http://schemas.openxmlformats.org/officeDocument/2006/relationships" xmlns:p="http://schemas.openxmlformats.org/presentationml/2006/main">
   <p:cSld>
     <p:spTree>
@@ -2934,7 +3139,22 @@
           <a:p>
             <a:r>
               <a:rPr lang="en-US" dirty="0"/>
-              <a:t/>
+              <a:t>Five files. arg_parse.py owns every command-line flag, main.py owns the
+counting and the printing. Say that out loud before you start, because the
+whole demo turns on it.
+Step 2 is the moment: it proposes a rewrite of a file it has never read,
+and what is on screen is a diff, so the minus lines are a line-by-line
+inventory of what it got wrong. Point at -default=DEFAULT_TOP_N against
++default=10.
+Two prompts to decline there, not one. The second one defaults to Yes, and
+taking the default writes the invented file to disk and loses the demo.
+Step 4 is the lecture in one sentence: same model, same prompt, one more
+file.
+Step 6 drops and re-adds on purpose. Without it all five files are still in
+context and the 4B cannot reproduce the failure. Same mistake, faster: the
+failure was never the model.
+If a step misbehaves, say the sentence and move on. The model can only
+change files that are in context.</a:t>
             </a:r>
             <a:endParaRPr lang="en-US" dirty="0"/>
           </a:p>
@@ -2957,7 +3177,7 @@
           <a:p>
             <a:fld id="{F7021451-1387-4CA6-816F-3879F97B5CBC}" type="slidenum">
               <a:rPr lang="en-US"/>
-              <a:t>34</a:t>
+              <a:t>35</a:t>
             </a:fld>
             <a:endParaRPr lang="en-US"/>
           </a:p>
@@ -2976,7 +3196,7 @@
 </p:notes>
 </file>
 
-<file path=ppt/notesSlides/notesSlide35.xml><?xml version="1.0" encoding="utf-8"?>
+<file path=ppt/notesSlides/notesSlide36.xml><?xml version="1.0" encoding="utf-8"?>
 <p:notes xmlns:a="http://schemas.openxmlformats.org/drawingml/2006/main" xmlns:r="http://schemas.openxmlformats.org/officeDocument/2006/relationships" xmlns:p="http://schemas.openxmlformats.org/presentationml/2006/main">
   <p:cSld>
     <p:spTree>
@@ -3022,7 +3242,22 @@
           <a:p>
             <a:r>
               <a:rPr lang="en-US" dirty="0"/>
-              <a:t/>
+              <a:t>Five files. arg_parse.py owns every command-line flag, main.py owns the
+counting and the printing. Say that out loud before you start, because the
+whole demo turns on it.
+Step 2 is the moment: it proposes a rewrite of a file it has never read,
+and what is on screen is a diff, so the minus lines are a line-by-line
+inventory of what it got wrong. Point at -default=DEFAULT_TOP_N against
++default=10.
+Two prompts to decline there, not one. The second one defaults to Yes, and
+taking the default writes the invented file to disk and loses the demo.
+Step 4 is the lecture in one sentence: same model, same prompt, one more
+file.
+Step 6 drops and re-adds on purpose. Without it all five files are still in
+context and the 4B cannot reproduce the failure. Same mistake, faster: the
+failure was never the model.
+If a step misbehaves, say the sentence and move on. The model can only
+change files that are in context.</a:t>
             </a:r>
             <a:endParaRPr lang="en-US" dirty="0"/>
           </a:p>
@@ -3045,7 +3280,7 @@
           <a:p>
             <a:fld id="{F7021451-1387-4CA6-816F-3879F97B5CBC}" type="slidenum">
               <a:rPr lang="en-US"/>
-              <a:t>35</a:t>
+              <a:t>36</a:t>
             </a:fld>
             <a:endParaRPr lang="en-US"/>
           </a:p>
@@ -3064,7 +3299,7 @@
 </p:notes>
 </file>
 
-<file path=ppt/notesSlides/notesSlide36.xml><?xml version="1.0" encoding="utf-8"?>
+<file path=ppt/notesSlides/notesSlide37.xml><?xml version="1.0" encoding="utf-8"?>
 <p:notes xmlns:a="http://schemas.openxmlformats.org/drawingml/2006/main" xmlns:r="http://schemas.openxmlformats.org/officeDocument/2006/relationships" xmlns:p="http://schemas.openxmlformats.org/presentationml/2006/main">
   <p:cSld>
     <p:spTree>
@@ -3110,7 +3345,22 @@
           <a:p>
             <a:r>
               <a:rPr lang="en-US" dirty="0"/>
-              <a:t/>
+              <a:t>Five files. arg_parse.py owns every command-line flag, main.py owns the
+counting and the printing. Say that out loud before you start, because the
+whole demo turns on it.
+Step 2 is the moment: it proposes a rewrite of a file it has never read,
+and what is on screen is a diff, so the minus lines are a line-by-line
+inventory of what it got wrong. Point at -default=DEFAULT_TOP_N against
++default=10.
+Two prompts to decline there, not one. The second one defaults to Yes, and
+taking the default writes the invented file to disk and loses the demo.
+Step 4 is the lecture in one sentence: same model, same prompt, one more
+file.
+Step 6 drops and re-adds on purpose. Without it all five files are still in
+context and the 4B cannot reproduce the failure. Same mistake, faster: the
+failure was never the model.
+If a step misbehaves, say the sentence and move on. The model can only
+change files that are in context.</a:t>
             </a:r>
             <a:endParaRPr lang="en-US" dirty="0"/>
           </a:p>
@@ -3133,7 +3383,7 @@
           <a:p>
             <a:fld id="{F7021451-1387-4CA6-816F-3879F97B5CBC}" type="slidenum">
               <a:rPr lang="en-US"/>
-              <a:t>36</a:t>
+              <a:t>37</a:t>
             </a:fld>
             <a:endParaRPr lang="en-US"/>
           </a:p>
@@ -3152,7 +3402,7 @@
 </p:notes>
 </file>
 
-<file path=ppt/notesSlides/notesSlide37.xml><?xml version="1.0" encoding="utf-8"?>
+<file path=ppt/notesSlides/notesSlide38.xml><?xml version="1.0" encoding="utf-8"?>
 <p:notes xmlns:a="http://schemas.openxmlformats.org/drawingml/2006/main" xmlns:r="http://schemas.openxmlformats.org/officeDocument/2006/relationships" xmlns:p="http://schemas.openxmlformats.org/presentationml/2006/main">
   <p:cSld>
     <p:spTree>
@@ -3198,7 +3448,22 @@
           <a:p>
             <a:r>
               <a:rPr lang="en-US" dirty="0"/>
-              <a:t/>
+              <a:t>Five files. arg_parse.py owns every command-line flag, main.py owns the
+counting and the printing. Say that out loud before you start, because the
+whole demo turns on it.
+Step 2 is the moment: it proposes a rewrite of a file it has never read,
+and what is on screen is a diff, so the minus lines are a line-by-line
+inventory of what it got wrong. Point at -default=DEFAULT_TOP_N against
++default=10.
+Two prompts to decline there, not one. The second one defaults to Yes, and
+taking the default writes the invented file to disk and loses the demo.
+Step 4 is the lecture in one sentence: same model, same prompt, one more
+file.
+Step 6 drops and re-adds on purpose. Without it all five files are still in
+context and the 4B cannot reproduce the failure. Same mistake, faster: the
+failure was never the model.
+If a step misbehaves, say the sentence and move on. The model can only
+change files that are in context.</a:t>
             </a:r>
             <a:endParaRPr lang="en-US" dirty="0"/>
           </a:p>
@@ -3221,7 +3486,7 @@
           <a:p>
             <a:fld id="{F7021451-1387-4CA6-816F-3879F97B5CBC}" type="slidenum">
               <a:rPr lang="en-US"/>
-              <a:t>37</a:t>
+              <a:t>38</a:t>
             </a:fld>
             <a:endParaRPr lang="en-US"/>
           </a:p>
@@ -3240,94 +3505,6 @@
 </p:notes>
 </file>
 
-<file path=ppt/notesSlides/notesSlide38.xml><?xml version="1.0" encoding="utf-8"?>
-<p:notes xmlns:a="http://schemas.openxmlformats.org/drawingml/2006/main" xmlns:r="http://schemas.openxmlformats.org/officeDocument/2006/relationships" xmlns:p="http://schemas.openxmlformats.org/presentationml/2006/main">
-  <p:cSld>
-    <p:spTree>
-      <p:nvGrpSpPr>
-        <p:cNvPr id="1" name=""/>
-        <p:cNvGrpSpPr/>
-        <p:nvPr/>
-      </p:nvGrpSpPr>
-      <p:grpSpPr>
-        <a:xfrm>
-          <a:off x="0" y="0"/>
-          <a:ext cx="0" cy="0"/>
-          <a:chOff x="0" y="0"/>
-          <a:chExt cx="0" cy="0"/>
-        </a:xfrm>
-      </p:grpSpPr>
-      <p:sp>
-        <p:nvSpPr>
-          <p:cNvPr id="2" name="Slide Image Placeholder 1"/>
-          <p:cNvSpPr>
-            <a:spLocks noGrp="1" noRot="1" noChangeAspect="1"/>
-          </p:cNvSpPr>
-          <p:nvPr>
-            <p:ph type="sldImg"/>
-          </p:nvPr>
-        </p:nvSpPr>
-        <p:spPr/>
-      </p:sp>
-      <p:sp>
-        <p:nvSpPr>
-          <p:cNvPr id="3" name="Notes Placeholder 2"/>
-          <p:cNvSpPr>
-            <a:spLocks noGrp="1"/>
-          </p:cNvSpPr>
-          <p:nvPr>
-            <p:ph type="body" idx="1"/>
-          </p:nvPr>
-        </p:nvSpPr>
-        <p:spPr/>
-        <p:txBody>
-          <a:bodyPr/>
-          <a:lstStyle/>
-          <a:p>
-            <a:r>
-              <a:rPr lang="en-US" dirty="0"/>
-              <a:t/>
-            </a:r>
-            <a:endParaRPr lang="en-US" dirty="0"/>
-          </a:p>
-        </p:txBody>
-      </p:sp>
-      <p:sp>
-        <p:nvSpPr>
-          <p:cNvPr id="4" name="Slide Number Placeholder 3"/>
-          <p:cNvSpPr>
-            <a:spLocks noGrp="1"/>
-          </p:cNvSpPr>
-          <p:nvPr>
-            <p:ph type="sldNum" sz="quarter" idx="10"/>
-          </p:nvPr>
-        </p:nvSpPr>
-        <p:spPr/>
-        <p:txBody>
-          <a:bodyPr/>
-          <a:lstStyle/>
-          <a:p>
-            <a:fld id="{F7021451-1387-4CA6-816F-3879F97B5CBC}" type="slidenum">
-              <a:rPr lang="en-US"/>
-              <a:t>38</a:t>
-            </a:fld>
-            <a:endParaRPr lang="en-US"/>
-          </a:p>
-        </p:txBody>
-      </p:sp>
-    </p:spTree>
-    <p:extLst>
-      <p:ext uri="{BB962C8B-B14F-4D97-AF65-F5344CB8AC3E}">
-        <p14:creationId xmlns:p14="http://schemas.microsoft.com/office/powerpoint/2010/main" val="1024086991"/>
-      </p:ext>
-    </p:extLst>
-  </p:cSld>
-  <p:clrMapOvr>
-    <a:masterClrMapping/>
-  </p:clrMapOvr>
-</p:notes>
-</file>
-
 <file path=ppt/notesSlides/notesSlide39.xml><?xml version="1.0" encoding="utf-8"?>
 <p:notes xmlns:a="http://schemas.openxmlformats.org/drawingml/2006/main" xmlns:r="http://schemas.openxmlformats.org/officeDocument/2006/relationships" xmlns:p="http://schemas.openxmlformats.org/presentationml/2006/main">
   <p:cSld>
@@ -3374,7 +3551,22 @@
           <a:p>
             <a:r>
               <a:rPr lang="en-US" dirty="0"/>
-              <a:t/>
+              <a:t>Five files. arg_parse.py owns every command-line flag, main.py owns the
+counting and the printing. Say that out loud before you start, because the
+whole demo turns on it.
+Step 2 is the moment: it proposes a rewrite of a file it has never read,
+and what is on screen is a diff, so the minus lines are a line-by-line
+inventory of what it got wrong. Point at -default=DEFAULT_TOP_N against
++default=10.
+Two prompts to decline there, not one. The second one defaults to Yes, and
+taking the default writes the invented file to disk and loses the demo.
+Step 4 is the lecture in one sentence: same model, same prompt, one more
+file.
+Step 6 drops and re-adds on purpose. Without it all five files are still in
+context and the 4B cannot reproduce the failure. Same mistake, faster: the
+failure was never the model.
+If a step misbehaves, say the sentence and move on. The model can only
+change files that are in context.</a:t>
             </a:r>
             <a:endParaRPr lang="en-US" dirty="0"/>
           </a:p>
@@ -3553,7 +3745,9 @@
           <a:p>
             <a:r>
               <a:rPr lang="en-US" dirty="0"/>
-              <a:t/>
+              <a:t>Not rhetorical. Ask them to actually answer these before Lab01.
+Question 2 is the one most of them get wrong: worse, not merely more
+expensive.</a:t>
             </a:r>
             <a:endParaRPr lang="en-US" dirty="0"/>
           </a:p>
@@ -3641,7 +3835,10 @@
           <a:p>
             <a:r>
               <a:rPr lang="en-US" dirty="0"/>
-              <a:t/>
+              <a:t>The concrete payoff: /add and /drop are one of the seven features they
+implement in weeks 3 and 4. Pulling a file into context is another, and
+the trimming behind multi-turn history is a third.
+They are drilling this week the exact behaviour they will have to write.</a:t>
             </a:r>
             <a:endParaRPr lang="en-US" dirty="0"/>
           </a:p>
@@ -3729,7 +3926,12 @@
           <a:p>
             <a:r>
               <a:rPr lang="en-US" dirty="0"/>
-              <a:t/>
+              <a:t>Friday is the gate and all sixteen lessons, both.
+They are not building yet. The build starts after Lab01 and the spec is
+graded with it.
+Thursday is Spec-Driven Coding: plan equals prompt, the artifact that makes
+"be concrete" reproducible at scale, and the last technique before the
+build.</a:t>
             </a:r>
             <a:endParaRPr lang="en-US" dirty="0"/>
           </a:p>
@@ -3817,7 +4019,12 @@
           <a:p>
             <a:r>
               <a:rPr lang="en-US" dirty="0"/>
-              <a:t/>
+              <a:t>Friday is the gate and all sixteen lessons, both.
+They are not building yet. The build starts after Lab01 and the spec is
+graded with it.
+Thursday is Spec-Driven Coding: plan equals prompt, the artifact that makes
+"be concrete" reproducible at scale, and the last technique before the
+build.</a:t>
             </a:r>
             <a:endParaRPr lang="en-US" dirty="0"/>
           </a:p>
@@ -3905,7 +4112,12 @@
           <a:p>
             <a:r>
               <a:rPr lang="en-US" dirty="0"/>
-              <a:t/>
+              <a:t>Friday is the gate and all sixteen lessons, both.
+They are not building yet. The build starts after Lab01 and the spec is
+graded with it.
+Thursday is Spec-Driven Coding: plan equals prompt, the artifact that makes
+"be concrete" reproducible at scale, and the last technique before the
+build.</a:t>
             </a:r>
             <a:endParaRPr lang="en-US" dirty="0"/>
           </a:p>
@@ -3993,7 +4205,12 @@
           <a:p>
             <a:r>
               <a:rPr lang="en-US" dirty="0"/>
-              <a:t/>
+              <a:t>Friday is the gate and all sixteen lessons, both.
+They are not building yet. The build starts after Lab01 and the spec is
+graded with it.
+Thursday is Spec-Driven Coding: plan equals prompt, the artifact that makes
+"be concrete" reproducible at scale, and the last technique before the
+build.</a:t>
             </a:r>
             <a:endParaRPr lang="en-US" dirty="0"/>
           </a:p>
@@ -4081,7 +4298,12 @@
           <a:p>
             <a:r>
               <a:rPr lang="en-US" dirty="0"/>
-              <a:t/>
+              <a:t>Friday is the gate and all sixteen lessons, both.
+They are not building yet. The build starts after Lab01 and the spec is
+graded with it.
+Thursday is Spec-Driven Coding: plan equals prompt, the artifact that makes
+"be concrete" reproducible at scale, and the last technique before the
+build.</a:t>
             </a:r>
             <a:endParaRPr lang="en-US" dirty="0"/>
           </a:p>
@@ -4123,6 +4345,94 @@
 </p:notes>
 </file>
 
+<file path=ppt/notesSlides/notesSlide47.xml><?xml version="1.0" encoding="utf-8"?>
+<p:notes xmlns:a="http://schemas.openxmlformats.org/drawingml/2006/main" xmlns:r="http://schemas.openxmlformats.org/officeDocument/2006/relationships" xmlns:p="http://schemas.openxmlformats.org/presentationml/2006/main">
+  <p:cSld>
+    <p:spTree>
+      <p:nvGrpSpPr>
+        <p:cNvPr id="1" name=""/>
+        <p:cNvGrpSpPr/>
+        <p:nvPr/>
+      </p:nvGrpSpPr>
+      <p:grpSpPr>
+        <a:xfrm>
+          <a:off x="0" y="0"/>
+          <a:ext cx="0" cy="0"/>
+          <a:chOff x="0" y="0"/>
+          <a:chExt cx="0" cy="0"/>
+        </a:xfrm>
+      </p:grpSpPr>
+      <p:sp>
+        <p:nvSpPr>
+          <p:cNvPr id="2" name="Slide Image Placeholder 1"/>
+          <p:cNvSpPr>
+            <a:spLocks noGrp="1" noRot="1" noChangeAspect="1"/>
+          </p:cNvSpPr>
+          <p:nvPr>
+            <p:ph type="sldImg"/>
+          </p:nvPr>
+        </p:nvSpPr>
+        <p:spPr/>
+      </p:sp>
+      <p:sp>
+        <p:nvSpPr>
+          <p:cNvPr id="3" name="Notes Placeholder 2"/>
+          <p:cNvSpPr>
+            <a:spLocks noGrp="1"/>
+          </p:cNvSpPr>
+          <p:nvPr>
+            <p:ph type="body" idx="1"/>
+          </p:nvPr>
+        </p:nvSpPr>
+        <p:spPr/>
+        <p:txBody>
+          <a:bodyPr/>
+          <a:lstStyle/>
+          <a:p>
+            <a:r>
+              <a:rPr lang="en-US" dirty="0"/>
+              <a:t/>
+            </a:r>
+            <a:endParaRPr lang="en-US" dirty="0"/>
+          </a:p>
+        </p:txBody>
+      </p:sp>
+      <p:sp>
+        <p:nvSpPr>
+          <p:cNvPr id="4" name="Slide Number Placeholder 3"/>
+          <p:cNvSpPr>
+            <a:spLocks noGrp="1"/>
+          </p:cNvSpPr>
+          <p:nvPr>
+            <p:ph type="sldNum" sz="quarter" idx="10"/>
+          </p:nvPr>
+        </p:nvSpPr>
+        <p:spPr/>
+        <p:txBody>
+          <a:bodyPr/>
+          <a:lstStyle/>
+          <a:p>
+            <a:fld id="{F7021451-1387-4CA6-816F-3879F97B5CBC}" type="slidenum">
+              <a:rPr lang="en-US"/>
+              <a:t>47</a:t>
+            </a:fld>
+            <a:endParaRPr lang="en-US"/>
+          </a:p>
+        </p:txBody>
+      </p:sp>
+    </p:spTree>
+    <p:extLst>
+      <p:ext uri="{BB962C8B-B14F-4D97-AF65-F5344CB8AC3E}">
+        <p14:creationId xmlns:p14="http://schemas.microsoft.com/office/powerpoint/2010/main" val="1024086991"/>
+      </p:ext>
+    </p:extLst>
+  </p:cSld>
+  <p:clrMapOvr>
+    <a:masterClrMapping/>
+  </p:clrMapOvr>
+</p:notes>
+</file>
+
 <file path=ppt/notesSlides/notesSlide5.xml><?xml version="1.0" encoding="utf-8"?>
 <p:notes xmlns:a="http://schemas.openxmlformats.org/drawingml/2006/main" xmlns:r="http://schemas.openxmlformats.org/officeDocument/2006/relationships" xmlns:p="http://schemas.openxmlformats.org/presentationml/2006/main">
   <p:cSld>
@@ -4169,7 +4479,13 @@
           <a:p>
             <a:r>
               <a:rPr lang="en-US" dirty="0"/>
-              <a:t>The Bullseye. Magic happens at the intersection. Miss any one → off-target.</a:t>
+              <a:t>Draw it in the air first, then let the slide confirm it. Three circles,
+target at the intersection.
+Walk the three near-misses in order and ask which one they think is most
+common before you say it. Zone 1 is the demo at 1:00, so name it now and
+they will recognise it when it happens.
+Zones 2 and 3 are the honest ones: a weak model and a vague prompt both
+produce output that looks like progress.</a:t>
             </a:r>
             <a:endParaRPr lang="en-US" dirty="0"/>
           </a:p>
@@ -4257,7 +4573,8 @@
           <a:p>
             <a:r>
               <a:rPr lang="en-US" dirty="0"/>
-              <a:t/>
+              <a:t>The punchline of the diagram they just read. Say it flat, then move.
+Effort in the other two levers does not buy back the one you missed.</a:t>
             </a:r>
             <a:endParaRPr lang="en-US" dirty="0"/>
           </a:p>
@@ -4345,7 +4662,11 @@
           <a:p>
             <a:r>
               <a:rPr lang="en-US" dirty="0"/>
-              <a:t/>
+              <a:t>The key point of the lecture. When something comes back wrong, ask these
+three in order before you touch anything.
+Most students blame the model. It is statistically the least common cause.
+Usually it is context.
+Tell them now that they will use this in Lab01 next week.</a:t>
             </a:r>
             <a:endParaRPr lang="en-US" dirty="0"/>
           </a:p>
@@ -4433,7 +4754,9 @@
           <a:p>
             <a:r>
               <a:rPr lang="en-US" dirty="0"/>
-              <a:t/>
+              <a:t>The lever they control most directly, and the one that causes the most
+trouble. Most of the next twenty minutes lives here.
+In a few weeks they implement this themselves.</a:t>
             </a:r>
             <a:endParaRPr lang="en-US" dirty="0"/>
           </a:p>
@@ -4521,7 +4844,12 @@
           <a:p>
             <a:r>
               <a:rPr lang="en-US" dirty="0"/>
-              <a:t/>
+              <a:t>Added files are the only files the model can edit. Say that twice.
+The repo map is an auto-generated summary, not a substitute for adding the
+file.
+Chat history accumulates until /clear. That is the second pitfall, two
+slides from now.
+The system prompt is Aider's own, and the default is fine for now.</a:t>
             </a:r>
             <a:endParaRPr lang="en-US" dirty="0"/>
           </a:p>
@@ -6433,6 +6761,45 @@
 <file path=ppt/slides/slide46.xml><?xml version="1.0" encoding="utf-8"?>
 <p:sld xmlns:a="http://schemas.openxmlformats.org/drawingml/2006/main" xmlns:r="http://schemas.openxmlformats.org/officeDocument/2006/relationships" xmlns:p="http://schemas.openxmlformats.org/presentationml/2006/main">
   <p:cSld name="Slide 46">
+    <p:bg>
+      <p:bgPr>
+        <a:blipFill dpi="0" rotWithShape="1">
+          <a:blip r:embed="rId1">
+            <a:lum/>
+          </a:blip>
+          <a:srcRect/>
+          <a:stretch>
+            <a:fillRect/>
+          </a:stretch>
+        </a:blipFill>
+        <a:effectLst/>
+      </p:bgPr>
+    </p:bg>
+    <p:spTree>
+      <p:nvGrpSpPr>
+        <p:cNvPr id="1" name=""/>
+        <p:cNvGrpSpPr/>
+        <p:nvPr/>
+      </p:nvGrpSpPr>
+      <p:grpSpPr>
+        <a:xfrm>
+          <a:off x="0" y="0"/>
+          <a:ext cx="0" cy="0"/>
+          <a:chOff x="0" y="0"/>
+          <a:chExt cx="0" cy="0"/>
+        </a:xfrm>
+      </p:grpSpPr>
+    </p:spTree>
+  </p:cSld>
+  <p:clrMapOvr>
+    <a:masterClrMapping/>
+  </p:clrMapOvr>
+</p:sld>
+</file>
+
+<file path=ppt/slides/slide47.xml><?xml version="1.0" encoding="utf-8"?>
+<p:sld xmlns:a="http://schemas.openxmlformats.org/drawingml/2006/main" xmlns:r="http://schemas.openxmlformats.org/officeDocument/2006/relationships" xmlns:p="http://schemas.openxmlformats.org/presentationml/2006/main">
+  <p:cSld name="Slide 47">
     <p:bg>
       <p:bgPr>
         <a:blipFill dpi="0" rotWithShape="1">

</xml_diff>